<commit_message>
Add nightly local DOE agent artifacts
</commit_message>
<xml_diff>
--- a/agent-outputs/hypothetical-local-agent-suite/final/powerpoint-deck-builder/board-update/deck.pptx
+++ b/agent-outputs/hypothetical-local-agent-suite/final/powerpoint-deck-builder/board-update/deck.pptx
@@ -3020,7 +3020,7 @@
                 <a:ea typeface="Aptos Display" pitchFamily="34" charset="-122"/>
                 <a:cs typeface="Aptos Display" pitchFamily="34" charset="-120"/>
               </a:rPr>
-              <a:t>DOE Result</a:t>
+              <a:t>Research Accuracy</a:t>
             </a:r>
             <a:endParaRPr lang="en-US" sz="2600" dirty="0"/>
           </a:p>
@@ -3090,7 +3090,7 @@
                 <a:ea typeface="Aptos" pitchFamily="34" charset="-122"/>
                 <a:cs typeface="Aptos" pitchFamily="34" charset="-120"/>
               </a:rPr>
-              <a:t>Deck depth, document depth, and dashboard depth were varied</a:t>
+              <a:t>Claims move through source, confidence, and accuracy review tables</a:t>
             </a:r>
             <a:endParaRPr lang="en-US" sz="1620" dirty="0"/>
           </a:p>
@@ -3160,7 +3160,7 @@
                 <a:ea typeface="Aptos" pitchFamily="34" charset="-122"/>
                 <a:cs typeface="Aptos" pitchFamily="34" charset="-120"/>
               </a:rPr>
-              <a:t>Best setting uses richer artifacts with security pack</a:t>
+              <a:t>Research depth factor: default</a:t>
             </a:r>
             <a:endParaRPr lang="en-US" sz="1620" dirty="0"/>
           </a:p>
@@ -3324,7 +3324,7 @@
                 <a:ea typeface="Aptos Display" pitchFamily="34" charset="-122"/>
                 <a:cs typeface="Aptos Display" pitchFamily="34" charset="-120"/>
               </a:rPr>
-              <a:t>Decision</a:t>
+              <a:t>DOE Result</a:t>
             </a:r>
             <a:endParaRPr lang="en-US" sz="2600" dirty="0"/>
           </a:p>
@@ -3394,7 +3394,7 @@
                 <a:ea typeface="Aptos" pitchFamily="34" charset="-122"/>
                 <a:cs typeface="Aptos" pitchFamily="34" charset="-120"/>
               </a:rPr>
-              <a:t>Keep real-output artifact runner</a:t>
+              <a:t>Deck depth, document depth, and dashboard depth were varied</a:t>
             </a:r>
             <a:endParaRPr lang="en-US" sz="1620" dirty="0"/>
           </a:p>
@@ -3464,7 +3464,7 @@
                 <a:ea typeface="Aptos" pitchFamily="34" charset="-122"/>
                 <a:cs typeface="Aptos" pitchFamily="34" charset="-120"/>
               </a:rPr>
-              <a:t>Chunk long local model validation</a:t>
+              <a:t>Best setting uses richer artifacts with security pack</a:t>
             </a:r>
             <a:endParaRPr lang="en-US" sz="1620" dirty="0"/>
           </a:p>
@@ -3473,76 +3473,6 @@
       <p:sp>
         <p:nvSpPr>
           <p:cNvPr id="8" name="Shape 6"/>
-          <p:cNvSpPr/>
-          <p:nvPr/>
-        </p:nvSpPr>
-        <p:spPr>
-          <a:xfrm>
-            <a:off x="658368" y="2980944"/>
-            <a:ext cx="292608" cy="292608"/>
-          </a:xfrm>
-          <a:prstGeom prst="roundRect">
-            <a:avLst>
-              <a:gd name="adj" fmla="val 18750"/>
-            </a:avLst>
-          </a:prstGeom>
-          <a:solidFill>
-            <a:srgbClr val="2563EB"/>
-          </a:solidFill>
-          <a:ln w="12700">
-            <a:solidFill>
-              <a:srgbClr val="FFFFFF">
-                <a:alpha val="0"/>
-              </a:srgbClr>
-            </a:solidFill>
-            <a:prstDash val="solid"/>
-          </a:ln>
-        </p:spPr>
-      </p:sp>
-      <p:sp>
-        <p:nvSpPr>
-          <p:cNvPr id="9" name="Text 7"/>
-          <p:cNvSpPr/>
-          <p:nvPr/>
-        </p:nvSpPr>
-        <p:spPr>
-          <a:xfrm>
-            <a:off x="1115568" y="2944368"/>
-            <a:ext cx="9829800" cy="384048"/>
-          </a:xfrm>
-          <a:prstGeom prst="rect">
-            <a:avLst/>
-          </a:prstGeom>
-          <a:noFill/>
-          <a:ln/>
-        </p:spPr>
-        <p:txBody>
-          <a:bodyPr wrap="square" lIns="0" tIns="0" rIns="0" bIns="0" rtlCol="0" anchor="ctr">
-            <a:normAutofit/>
-          </a:bodyPr>
-          <a:lstStyle/>
-          <a:p>
-            <a:pPr indent="0" marL="0">
-              <a:buNone/>
-            </a:pPr>
-            <a:r>
-              <a:rPr lang="en-US" sz="1620" dirty="0">
-                <a:solidFill>
-                  <a:srgbClr val="374151"/>
-                </a:solidFill>
-                <a:latin typeface="Aptos" pitchFamily="34" charset="0"/>
-                <a:ea typeface="Aptos" pitchFamily="34" charset="-122"/>
-                <a:cs typeface="Aptos" pitchFamily="34" charset="-120"/>
-              </a:rPr>
-              <a:t>Promote passing artifacts into the UI build flow</a:t>
-            </a:r>
-            <a:endParaRPr lang="en-US" sz="1620" dirty="0"/>
-          </a:p>
-        </p:txBody>
-      </p:sp>
-      <p:sp>
-        <p:nvSpPr>
-          <p:cNvPr id="10" name="Shape 8"/>
           <p:cNvSpPr/>
           <p:nvPr/>
         </p:nvSpPr>
@@ -3567,7 +3497,7 @@
       </p:sp>
       <p:sp>
         <p:nvSpPr>
-          <p:cNvPr id="11" name="Text 9"/>
+          <p:cNvPr id="9" name="Text 7"/>
           <p:cNvSpPr/>
           <p:nvPr/>
         </p:nvSpPr>

</xml_diff>